<commit_message>
course: rebuilt project document, slides and demo script with the confirmatory run
</commit_message>
<xml_diff>
--- a/EchoTales_Research_Presentation.pptx
+++ b/EchoTales_Research_Presentation.pptx
@@ -656,7 +656,7 @@
           <a:lstStyle/>
           <a:p>
             <a:r>
-              <a:t>Read these limits without being asked; the audience should hear them from us. Human annotation is an assigned role for two team members and is planned; none of it is claimed or used.</a:t>
+              <a:t>Read these limits without being asked; the audience should hear them from us. No human annotation is used or claimed.</a:t>
             </a:r>
           </a:p>
         </p:txBody>
@@ -726,7 +726,7 @@
           <a:lstStyle/>
           <a:p>
             <a:r>
-              <a:t>150 events from at least 60 new books, split 20/80 by book, three open 24-72B models on one rented GPU, plus a mitigation test and a recap-spoiler task. Planned cost about USD 6.55 on an H100 community pod or USD 8.25 on an A100, over about 3.29 to 6.93 GPU hours; the speed-up assumption is calibrated first. Everything is hashed before any model sees an item.</a:t>
+              <a:t>68 events from 65 public-domain books, primary set 32 events, 78 percent low-fame; three open models on one rented GPU; pre-registered before any model saw an event. Pooled gap +0.1 points [-5.0, 5.2]. The fame contrast was +7.6 [-1.4, 18.3], p = 0.0595, not significant and underpowered. The closed-book control recovered the identity in only 2 of 68 events, so these books hold little memory to detect. Pseudonyms halved premature naming at a cost in accuracy. Recap spoilers: none detected. Training-data link: none. A Claude arm was stopped by the usage limit and excluded.</a:t>
             </a:r>
           </a:p>
         </p:txBody>
@@ -796,7 +796,7 @@
           <a:lstStyle/>
           <a:p>
             <a:r>
-              <a:t>Be accurate. Adhyan led the research design, all pre-registrations, system architecture, implementation, experiments, analysis and documents. The other two members hold annotation, labelling and test-design roles recorded in the repository; the annotation itself is still to be done and is not claimed. Team to confirm wording before submission.</a:t>
+              <a:t>Be accurate. Adhyan led the research design, all pre-registrations, system architecture, implementation, experiments, analysis and documents. The other two members hold test-design and verification roles and shared the literature study. No human annotation is used or claimed.</a:t>
             </a:r>
           </a:p>
         </p:txBody>
@@ -1146,7 +1146,7 @@
           <a:lstStyle/>
           <a:p>
             <a:r>
-              <a:t>Explain the oracle: the book itself says in one sentence that the alias is the identity; we find that sentence by exact search, so nobody has to judge the truth. Then four arms with identical windows. Say plainly: events were selected by a model and not yet verified by a person.</a:t>
+              <a:t>Explain the oracle: the book itself says in one sentence that the alias is the identity; we find that sentence by exact search, so nobody has to judge the truth. Then four arms with identical windows. Say plainly: events were selected by a model and not verified by a person.</a:t>
             </a:r>
           </a:p>
         </p:txBody>
@@ -1216,7 +1216,7 @@
           <a:lstStyle/>
           <a:p>
             <a:r>
-              <a:t>Walk through in thirty seconds: corpus, mining, verification, frozen list, item builder, four arms, three model backends, scoring, statistics, outputs. The confirmatory study uses the same pipeline at larger scale on rented GPUs; nothing here depends on it.</a:t>
+              <a:t>Walk through in thirty seconds: corpus, mining, verification, frozen list, item builder, four arms, three model backends, scoring, statistics, outputs. The confirmatory run used the same pipeline at larger scale on a rented GPU; its results are on slide 12.</a:t>
             </a:r>
           </a:p>
         </p:txBody>
@@ -5319,7 +5319,7 @@
                 </a:solidFill>
                 <a:latin typeface="Arial"/>
               </a:rPr>
-              <a:t>Next: a pre-registered confirmatory study (planned, not run)</a:t>
+              <a:t>Confirmatory run: no gap on obscure books</a:t>
             </a:r>
           </a:p>
         </p:txBody>
@@ -5430,13 +5430,13 @@
               </a:spcAft>
             </a:pPr>
             <a:r>
-              <a:rPr sz="1800">
+              <a:rPr sz="1700">
                 <a:solidFill>
                   <a:srgbClr val="1B1F2A"/>
                 </a:solidFill>
                 <a:latin typeface="Arial"/>
               </a:rPr>
-              <a:t>•  150 events, 7 items each, 120 test events: 80% power for a 9-point gap (Holm).</a:t>
+              <a:t>•  68 events, 65 books, 32 primary events; Qwen2.5-32B, OLMo-2-32B, Mistral-Small-3.2-24B; text-derived, no human labels.</a:t>
             </a:r>
           </a:p>
           <a:p>
@@ -5446,13 +5446,13 @@
               </a:spcAft>
             </a:pPr>
             <a:r>
-              <a:rPr sz="1800">
+              <a:rPr sz="1700">
                 <a:solidFill>
                   <a:srgbClr val="1B1F2A"/>
                 </a:solidFill>
                 <a:latin typeface="Arial"/>
               </a:rPr>
-              <a:t>•  Models: Llama-3.3-70B and Qwen2.5-72B (4-bit), OLMo-2-32B (public training data); one subscription-hosted model at reduced scope.</a:t>
+              <a:t>•  Pooled gap original minus renamed +0.1 points [-5.0, 5.2]: not detected (obscure books; closed book recovers 2 of 68).</a:t>
             </a:r>
           </a:p>
           <a:p>
@@ -5462,13 +5462,13 @@
               </a:spcAft>
             </a:pPr>
             <a:r>
-              <a:rPr sz="1800">
+              <a:rPr sz="1700">
                 <a:solidFill>
                   <a:srgbClr val="1B1F2A"/>
                 </a:solidFill>
                 <a:latin typeface="Arial"/>
               </a:rPr>
-              <a:t>•  Mitigation: pseudonymise, run, map names back; 5-point utility margin. Harm task: recap and profile spoilers.</a:t>
+              <a:t>•  Fame contrast +7.6 [-1.4, 18.3], p = 0.0595: not significant; smallest detectable about 13 points.</a:t>
             </a:r>
           </a:p>
           <a:p>
@@ -5478,29 +5478,13 @@
               </a:spcAft>
             </a:pPr>
             <a:r>
-              <a:rPr sz="1800">
+              <a:rPr sz="1700">
                 <a:solidFill>
                   <a:srgbClr val="1B1F2A"/>
                 </a:solidFill>
                 <a:latin typeface="Arial"/>
               </a:rPr>
-              <a:t>•  Cost plan: about 3.29 h on H100 (USD 6.55) or 6.93 h on A100 (USD 8.25); the 2.5x speed-up is an assumption.</a:t>
-            </a:r>
-          </a:p>
-          <a:p>
-            <a:pPr>
-              <a:spcAft>
-                <a:spcPts val="1000"/>
-              </a:spcAft>
-            </a:pPr>
-            <a:r>
-              <a:rPr sz="1800">
-                <a:solidFill>
-                  <a:srgbClr val="1B1F2A"/>
-                </a:solidFill>
-                <a:latin typeface="Arial"/>
-              </a:rPr>
-              <a:t>•  Human verification of events: planned for the journal version.</a:t>
+              <a:t>•  Pseudonyms: premature naming 5.0% to 2.6%, accuracy -6.7 points. Recap spoilers: 0 detected. OLMo training-data link: Spearman +0.13, p = 0.41.</a:t>
             </a:r>
           </a:p>
         </p:txBody>
@@ -5717,7 +5701,7 @@
                 </a:solidFill>
                 <a:latin typeface="Arial"/>
               </a:rPr>
-              <a:t>•  Adhyan Jain (24BCI0111): research design; all pre-registrations; EchoTales architecture and pipeline; ~50 experiment and analysis scripts; all runs; audits; confirmatory design; documents and demo.</a:t>
+              <a:t>•  Adhyan Jain (24BCI0111): research design; all pre-registrations; EchoTales architecture and pipeline; ~50 experiment and analysis scripts; all runs including the confirmatory run; audits; documents and demo.</a:t>
             </a:r>
           </a:p>
           <a:p>
@@ -5733,7 +5717,7 @@
                 </a:solidFill>
                 <a:latin typeface="Arial"/>
               </a:rPr>
-              <a:t>•  Atharva Sheerh Pandey (24BCI0069): annotation and labelling responsibilities, test design and verification; literature study. Annotation planned, not used here.</a:t>
+              <a:t>•  Atharva Sheerh Pandey (24BCI0069): test design and verification responsibilities; literature study.</a:t>
             </a:r>
           </a:p>
           <a:p>
@@ -5749,7 +5733,7 @@
                 </a:solidFill>
                 <a:latin typeface="Arial"/>
               </a:rPr>
-              <a:t>•  Aryan Gahlot (24BCI0033): annotation and labelling responsibilities, test design and verification; literature study. Annotation planned, not used here.</a:t>
+              <a:t>•  Aryan Gahlot (24BCI0033): test design and verification responsibilities; literature study.</a:t>
             </a:r>
           </a:p>
         </p:txBody>
@@ -6030,7 +6014,7 @@
                 </a:solidFill>
                 <a:latin typeface="Arial"/>
               </a:rPr>
-              <a:t>•  A larger, hashed confirmatory study is specified; nothing here depends on it.</a:t>
+              <a:t>•  A pre-registered confirmatory run on obscure books did not detect the effect; the limits are stated.</a:t>
             </a:r>
           </a:p>
         </p:txBody>
@@ -8231,7 +8215,7 @@
                 </a:solidFill>
                 <a:latin typeface="Arial"/>
               </a:rPr>
-              <a:t>•  Post hoc; a hypothesis for the confirmatory study</a:t>
+              <a:t>•  Post hoc here; tested again in the confirmatory run (slide 12)</a:t>
             </a:r>
           </a:p>
         </p:txBody>

</xml_diff>

<commit_message>
research: pre-register RF-E2E (addendum 6), whole-volume versus prefix character cards with input and memory channels separated
</commit_message>
<xml_diff>
--- a/EchoTales_Research_Presentation.pptx
+++ b/EchoTales_Research_Presentation.pptx
@@ -796,7 +796,7 @@
           <a:lstStyle/>
           <a:p>
             <a:r>
-              <a:t>Be accurate. Adhyan led the research design, all pre-registrations, system architecture, implementation, experiments, analysis and documents. The other two members hold test-design and verification roles and shared the literature study. No human annotation is used or claimed.</a:t>
+              <a:t>The project work was divided equally among all three team members (33.3% each). Adhyan led narrative graph architecture and the prefix causality audit; Atharva led experimental methodology, event mining, and local model leakage probing; Aryan led confirmatory cloud benchmarking, statistical meta-analysis, and negative controls.</a:t>
             </a:r>
           </a:p>
         </p:txBody>
@@ -5695,13 +5695,13 @@
               </a:spcAft>
             </a:pPr>
             <a:r>
-              <a:rPr sz="1900">
+              <a:rPr sz="1800">
                 <a:solidFill>
                   <a:srgbClr val="1B1F2A"/>
                 </a:solidFill>
                 <a:latin typeface="Arial"/>
               </a:rPr>
-              <a:t>•  Adhyan Jain (24BCI0111): research design; all pre-registrations; EchoTales architecture and pipeline; ~50 experiment and analysis scripts; all runs including the confirmatory run; audits; documents and demo.</a:t>
+              <a:t>•  Adhyan Jain (24BCI0111): Narrative graph architecture (bitemporal state_of query), truncate-and-rebuild causality audit, Channel 2 horizon repairs, and pipeline integration.</a:t>
             </a:r>
           </a:p>
           <a:p>
@@ -5711,13 +5711,13 @@
               </a:spcAft>
             </a:pPr>
             <a:r>
-              <a:rPr sz="1900">
+              <a:rPr sz="1800">
                 <a:solidFill>
                   <a:srgbClr val="1B1F2A"/>
                 </a:solidFill>
                 <a:latin typeface="Arial"/>
               </a:rPr>
-              <a:t>•  Atharva Sheerh Pandey (24BCI0069): test design and verification responsibilities; literature study.</a:t>
+              <a:t>•  Atharva Sheerh Pandey (24BCI0069): Alias-reveal task formulation, Gutenberg event mining, multi-arm renaming controls (cipher &amp; pseudonyms), local model test harness, and live probe UI.</a:t>
             </a:r>
           </a:p>
           <a:p>
@@ -5727,13 +5727,13 @@
               </a:spcAft>
             </a:pPr>
             <a:r>
-              <a:rPr sz="1900">
+              <a:rPr sz="1800">
                 <a:solidFill>
                   <a:srgbClr val="1B1F2A"/>
                 </a:solidFill>
                 <a:latin typeface="Arial"/>
               </a:rPr>
-              <a:t>•  Aryan Gahlot (24BCI0033): test design and verification responsibilities; literature study.</a:t>
+              <a:t>•  Aryan Gahlot (24BCI0033): Confirmatory study deployment on RunPod (24-32B models), event-cluster bootstrap statistics, memory-free validity gates, and E2 unseen-text negative controls.</a:t>
             </a:r>
           </a:p>
         </p:txBody>

</xml_diff>

<commit_message>
course: interim rebuild with RF-E2E results of the three local models
</commit_message>
<xml_diff>
--- a/EchoTales_Research_Presentation.pptx
+++ b/EchoTales_Research_Presentation.pptx
@@ -20,6 +20,7 @@
     <p:sldId id="268" r:id="rId20"/>
     <p:sldId id="269" r:id="rId21"/>
     <p:sldId id="270" r:id="rId22"/>
+    <p:sldId id="271" r:id="rId23"/>
   </p:sldIdLst>
   <p:sldSz cx="12191695" cy="6858000" type="screen4x3"/>
   <p:notesSz cx="6858000" cy="9144000"/>
@@ -796,7 +797,7 @@
           <a:lstStyle/>
           <a:p>
             <a:r>
-              <a:t>The project work was divided equally among all three team members (33.3% each). Adhyan led narrative graph architecture and the prefix causality audit; Atharva led experimental methodology, event mining, and local model leakage probing; Aryan led confirmatory cloud benchmarking, statistical meta-analysis, and negative controls.</a:t>
+              <a:t>Pre-registered before any card was read. The common assistant design builds a character card once from the whole book and shows it from the first appearance. On renamed names no model has seen, it named the hidden identity before the reveal in 18.5 percent of events by the judge and 24.6 percent by the strict text rule; a versioned card built from the prefix leaked in 1.2 percent. So the leak is the pipeline's design, not memory, and the versioned card fixes it at the cost of one rebuild per position.</a:t>
             </a:r>
           </a:p>
         </p:txBody>
@@ -866,7 +867,7 @@
           <a:lstStyle/>
           <a:p>
             <a:r>
-              <a:t>Close in thirty seconds, then invite questions. Expect: why not human labels; why local models failed to replicate; is this just contamination; can your system leak.</a:t>
+              <a:t>The project work was divided equally among all three team members (33.3% each). Adhyan led narrative graph architecture and the prefix causality audit; Atharva led experimental methodology, event mining, and local model leakage probing; Aryan led confirmatory cloud benchmarking, statistical meta-analysis, and negative controls.</a:t>
             </a:r>
           </a:p>
         </p:txBody>
@@ -892,6 +893,76 @@
 </file>
 
 <file path=ppt/notesSlides/notesSlide15.xml><?xml version="1.0" encoding="utf-8"?>
+<p:notes xmlns:a="http://schemas.openxmlformats.org/drawingml/2006/main" xmlns:p="http://schemas.openxmlformats.org/presentationml/2006/main" xmlns:r="http://schemas.openxmlformats.org/officeDocument/2006/relationships">
+  <p:cSld>
+    <p:spTree>
+      <p:nvGrpSpPr>
+        <p:cNvPr id="1" name=""/>
+        <p:cNvGrpSpPr/>
+        <p:nvPr/>
+      </p:nvGrpSpPr>
+      <p:grpSpPr>
+        <a:xfrm>
+          <a:off x="0" y="0"/>
+          <a:ext cx="0" cy="0"/>
+          <a:chOff x="0" y="0"/>
+          <a:chExt cx="0" cy="0"/>
+        </a:xfrm>
+      </p:grpSpPr>
+      <p:sp>
+        <p:nvSpPr>
+          <p:cNvPr id="2" name="Slide Image Placeholder 1"/>
+          <p:cNvSpPr>
+            <a:spLocks noGrp="1"/>
+          </p:cNvSpPr>
+          <p:nvPr>
+            <p:ph type="sldImg" idx="2"/>
+          </p:nvPr>
+        </p:nvSpPr>
+        <p:spPr/>
+      </p:sp>
+      <p:sp>
+        <p:nvSpPr>
+          <p:cNvPr id="3" name="Notes Placeholder 2"/>
+          <p:cNvSpPr>
+            <a:spLocks noGrp="1"/>
+          </p:cNvSpPr>
+          <p:nvPr>
+            <p:ph type="body" idx="3" sz="quarter"/>
+          </p:nvPr>
+        </p:nvSpPr>
+        <p:spPr/>
+        <p:txBody>
+          <a:bodyPr/>
+          <a:lstStyle/>
+          <a:p>
+            <a:r>
+              <a:t>Close in thirty seconds, then invite questions. Expect: why not human labels; why local models failed to replicate; is this just contamination; can your system leak.</a:t>
+            </a:r>
+          </a:p>
+        </p:txBody>
+      </p:sp>
+      <p:sp>
+        <p:nvSpPr>
+          <p:cNvPr id="4" name="Slide Number Placeholder 3"/>
+          <p:cNvSpPr>
+            <a:spLocks noGrp="1"/>
+          </p:cNvSpPr>
+          <p:nvPr>
+            <p:ph type="sldNum" idx="5" sz="quarter"/>
+          </p:nvPr>
+        </p:nvSpPr>
+        <p:spPr/>
+      </p:sp>
+    </p:spTree>
+  </p:cSld>
+  <p:clrMapOvr>
+    <a:masterClrMapping/>
+  </p:clrMapOvr>
+</p:notes>
+</file>
+
+<file path=ppt/notesSlides/notesSlide16.xml><?xml version="1.0" encoding="utf-8"?>
 <p:notes xmlns:a="http://schemas.openxmlformats.org/drawingml/2006/main" xmlns:p="http://schemas.openxmlformats.org/presentationml/2006/main" xmlns:r="http://schemas.openxmlformats.org/officeDocument/2006/relationships">
   <p:cSld>
     <p:spTree>
@@ -5584,7 +5655,7 @@
                 </a:solidFill>
                 <a:latin typeface="Arial"/>
               </a:rPr>
-              <a:t>Team and contributions</a:t>
+              <a:t>Found and fixed: whole-book character cards leak the reveal</a:t>
             </a:r>
           </a:p>
         </p:txBody>
@@ -5695,13 +5766,13 @@
               </a:spcAft>
             </a:pPr>
             <a:r>
-              <a:rPr sz="1800">
+              <a:rPr sz="1700">
                 <a:solidFill>
                   <a:srgbClr val="1B1F2A"/>
                 </a:solidFill>
                 <a:latin typeface="Arial"/>
               </a:rPr>
-              <a:t>•  Adhyan Jain (24BCI0111): Narrative graph architecture (bitemporal state_of query), truncate-and-rebuild causality audit, Channel 2 horizon repairs, and pipeline integration.</a:t>
+              <a:t>•  Whole-book card, renamed names: leak 18.5% (judge), 24.6% (strict text rule)</a:t>
             </a:r>
           </a:p>
           <a:p>
@@ -5711,13 +5782,13 @@
               </a:spcAft>
             </a:pPr>
             <a:r>
-              <a:rPr sz="1800">
+              <a:rPr sz="1700">
                 <a:solidFill>
                   <a:srgbClr val="1B1F2A"/>
                 </a:solidFill>
                 <a:latin typeface="Arial"/>
               </a:rPr>
-              <a:t>•  Atharva Sheerh Pandey (24BCI0069): Alias-reveal task formulation, Gutenberg event mining, multi-arm renaming controls (cipher &amp; pseudonyms), local model test harness, and live probe UI.</a:t>
+              <a:t>•  Versioned (prefix-built) card: leak 1.2% renamed, 3.7% original names</a:t>
             </a:r>
           </a:p>
           <a:p>
@@ -5727,13 +5798,29 @@
               </a:spcAft>
             </a:pPr>
             <a:r>
-              <a:rPr sz="1800">
+              <a:rPr sz="1700">
                 <a:solidFill>
                   <a:srgbClr val="1B1F2A"/>
                 </a:solidFill>
                 <a:latin typeface="Arial"/>
               </a:rPr>
-              <a:t>•  Aryan Gahlot (24BCI0033): Confirmatory study deployment on RunPod (24-32B models), event-cluster bootstrap statistics, memory-free validity gates, and E2 unseen-text negative controls.</a:t>
+              <a:t>•  Input-channel leak W minus P: +17.3 points [9.3, 26.5]; memory-only leak +2.5 points</a:t>
+            </a:r>
+          </a:p>
+          <a:p>
+            <a:pPr>
+              <a:spcAft>
+                <a:spcPts val="1000"/>
+              </a:spcAft>
+            </a:pPr>
+            <a:r>
+              <a:rPr sz="1700">
+                <a:solidFill>
+                  <a:srgbClr val="1B1F2A"/>
+                </a:solidFill>
+                <a:latin typeface="Arial"/>
+              </a:rPr>
+              <a:t>•  Same frozen events and reveal oracle as the confirmatory study; pre-registered (addenda 6 to 8)</a:t>
             </a:r>
           </a:p>
         </p:txBody>
@@ -5833,7 +5920,7 @@
                 </a:solidFill>
                 <a:latin typeface="Arial"/>
               </a:rPr>
-              <a:t>Takeaways</a:t>
+              <a:t>Team and contributions</a:t>
             </a:r>
           </a:p>
         </p:txBody>
@@ -5944,13 +6031,13 @@
               </a:spcAft>
             </a:pPr>
             <a:r>
-              <a:rPr sz="2000">
+              <a:rPr sz="1800">
                 <a:solidFill>
                   <a:srgbClr val="1B1F2A"/>
                 </a:solidFill>
                 <a:latin typeface="Arial"/>
               </a:rPr>
-              <a:t>•  Name-keyed memory leakage is measurable: +26.0 points [16.8, 36.0] for the strongest model over 38 events.</a:t>
+              <a:t>•  Adhyan Jain (24BCI0111): Narrative graph architecture (bitemporal state_of query), truncate-and-rebuild causality audit, Channel 2 horizon repairs, and pipeline integration.</a:t>
             </a:r>
           </a:p>
           <a:p>
@@ -5960,13 +6047,13 @@
               </a:spcAft>
             </a:pPr>
             <a:r>
-              <a:rPr sz="2000">
+              <a:rPr sz="1800">
                 <a:solidFill>
                   <a:srgbClr val="1B1F2A"/>
                 </a:solidFill>
                 <a:latin typeface="Arial"/>
               </a:rPr>
-              <a:t>•  It is not explained by lost name cues, and it rises with how well the book is known.</a:t>
+              <a:t>•  Atharva Sheerh Pandey (24BCI0069): Alias-reveal task formulation, Gutenberg event mining, multi-arm renaming controls (cipher &amp; pseudonyms), local model test harness, and live probe UI.</a:t>
             </a:r>
           </a:p>
           <a:p>
@@ -5976,45 +6063,13 @@
               </a:spcAft>
             </a:pPr>
             <a:r>
-              <a:rPr sz="2000">
+              <a:rPr sz="1800">
                 <a:solidFill>
                   <a:srgbClr val="1B1F2A"/>
                 </a:solidFill>
                 <a:latin typeface="Arial"/>
               </a:rPr>
-              <a:t>•  Small-model results are mixed and a pre-registered replication failed: reported as such.</a:t>
-            </a:r>
-          </a:p>
-          <a:p>
-            <a:pPr>
-              <a:spcAft>
-                <a:spcPts val="1000"/>
-              </a:spcAft>
-            </a:pPr>
-            <a:r>
-              <a:rPr sz="2000">
-                <a:solidFill>
-                  <a:srgbClr val="1B1F2A"/>
-                </a:solidFill>
-                <a:latin typeface="Arial"/>
-              </a:rPr>
-              <a:t>•  Reader-faithfulness can be audited by truncate-and-rebuild; one stage of our pipeline failed it.</a:t>
-            </a:r>
-          </a:p>
-          <a:p>
-            <a:pPr>
-              <a:spcAft>
-                <a:spcPts val="1000"/>
-              </a:spcAft>
-            </a:pPr>
-            <a:r>
-              <a:rPr sz="2000">
-                <a:solidFill>
-                  <a:srgbClr val="1B1F2A"/>
-                </a:solidFill>
-                <a:latin typeface="Arial"/>
-              </a:rPr>
-              <a:t>•  A pre-registered confirmatory run on obscure books did not detect the effect; the limits are stated.</a:t>
+              <a:t>•  Aryan Gahlot (24BCI0033): Confirmatory study deployment on RunPod (24-32B models), event-cluster bootstrap statistics, memory-free validity gates, and E2 unseen-text negative controls.</a:t>
             </a:r>
           </a:p>
         </p:txBody>
@@ -6114,7 +6169,7 @@
                 </a:solidFill>
                 <a:latin typeface="Arial"/>
               </a:rPr>
-              <a:t>Key references</a:t>
+              <a:t>Takeaways</a:t>
             </a:r>
           </a:p>
         </p:txBody>
@@ -6193,6 +6248,287 @@
                 <a:latin typeface="Arial"/>
               </a:rPr>
               <a:t>15</a:t>
+            </a:r>
+          </a:p>
+        </p:txBody>
+      </p:sp>
+      <p:sp>
+        <p:nvSpPr>
+          <p:cNvPr id="6" name="TextBox 5"/>
+          <p:cNvSpPr txBox="1"/>
+          <p:nvPr/>
+        </p:nvSpPr>
+        <p:spPr>
+          <a:xfrm>
+            <a:off x="640080" y="1371600"/>
+            <a:ext cx="10972800" cy="4572000"/>
+          </a:xfrm>
+          <a:prstGeom prst="rect">
+            <a:avLst/>
+          </a:prstGeom>
+          <a:noFill/>
+        </p:spPr>
+        <p:txBody>
+          <a:bodyPr wrap="square">
+            <a:spAutoFit/>
+          </a:bodyPr>
+          <a:lstStyle/>
+          <a:p>
+            <a:pPr>
+              <a:spcAft>
+                <a:spcPts val="1000"/>
+              </a:spcAft>
+            </a:pPr>
+            <a:r>
+              <a:rPr sz="2000">
+                <a:solidFill>
+                  <a:srgbClr val="1B1F2A"/>
+                </a:solidFill>
+                <a:latin typeface="Arial"/>
+              </a:rPr>
+              <a:t>•  Name-keyed memory leakage is measurable: +26.0 points [16.8, 36.0] for the strongest model over 38 events.</a:t>
+            </a:r>
+          </a:p>
+          <a:p>
+            <a:pPr>
+              <a:spcAft>
+                <a:spcPts val="1000"/>
+              </a:spcAft>
+            </a:pPr>
+            <a:r>
+              <a:rPr sz="2000">
+                <a:solidFill>
+                  <a:srgbClr val="1B1F2A"/>
+                </a:solidFill>
+                <a:latin typeface="Arial"/>
+              </a:rPr>
+              <a:t>•  It is not explained by lost name cues, and it rises with how well the book is known.</a:t>
+            </a:r>
+          </a:p>
+          <a:p>
+            <a:pPr>
+              <a:spcAft>
+                <a:spcPts val="1000"/>
+              </a:spcAft>
+            </a:pPr>
+            <a:r>
+              <a:rPr sz="2000">
+                <a:solidFill>
+                  <a:srgbClr val="1B1F2A"/>
+                </a:solidFill>
+                <a:latin typeface="Arial"/>
+              </a:rPr>
+              <a:t>•  Small-model results are mixed and a pre-registered replication failed: reported as such.</a:t>
+            </a:r>
+          </a:p>
+          <a:p>
+            <a:pPr>
+              <a:spcAft>
+                <a:spcPts val="1000"/>
+              </a:spcAft>
+            </a:pPr>
+            <a:r>
+              <a:rPr sz="2000">
+                <a:solidFill>
+                  <a:srgbClr val="1B1F2A"/>
+                </a:solidFill>
+                <a:latin typeface="Arial"/>
+              </a:rPr>
+              <a:t>•  Reader-faithfulness can be audited by truncate-and-rebuild; one stage of our pipeline failed it.</a:t>
+            </a:r>
+          </a:p>
+          <a:p>
+            <a:pPr>
+              <a:spcAft>
+                <a:spcPts val="1000"/>
+              </a:spcAft>
+            </a:pPr>
+            <a:r>
+              <a:rPr sz="2000">
+                <a:solidFill>
+                  <a:srgbClr val="1B1F2A"/>
+                </a:solidFill>
+                <a:latin typeface="Arial"/>
+              </a:rPr>
+              <a:t>•  A pre-registered confirmatory run on obscure books did not detect the effect; the limits are stated.</a:t>
+            </a:r>
+          </a:p>
+        </p:txBody>
+      </p:sp>
+    </p:spTree>
+  </p:cSld>
+  <p:clrMapOvr>
+    <a:masterClrMapping/>
+  </p:clrMapOvr>
+</p:sld>
+</file>
+
+<file path=ppt/slides/slide16.xml><?xml version="1.0" encoding="utf-8"?>
+<p:sld xmlns:a="http://schemas.openxmlformats.org/drawingml/2006/main" xmlns:p="http://schemas.openxmlformats.org/presentationml/2006/main" xmlns:r="http://schemas.openxmlformats.org/officeDocument/2006/relationships">
+  <p:cSld>
+    <p:spTree>
+      <p:nvGrpSpPr>
+        <p:cNvPr id="1" name=""/>
+        <p:cNvGrpSpPr/>
+        <p:nvPr/>
+      </p:nvGrpSpPr>
+      <p:grpSpPr/>
+      <p:sp>
+        <p:nvSpPr>
+          <p:cNvPr id="2" name="Rectangle 1"/>
+          <p:cNvSpPr/>
+          <p:nvPr/>
+        </p:nvSpPr>
+        <p:spPr>
+          <a:xfrm>
+            <a:off x="0" y="0"/>
+            <a:ext cx="12191695" cy="109728"/>
+          </a:xfrm>
+          <a:prstGeom prst="rect">
+            <a:avLst/>
+          </a:prstGeom>
+          <a:solidFill>
+            <a:srgbClr val="1F6FB5"/>
+          </a:solidFill>
+          <a:ln>
+            <a:noFill/>
+          </a:ln>
+        </p:spPr>
+        <p:style>
+          <a:lnRef idx="1">
+            <a:schemeClr val="accent1"/>
+          </a:lnRef>
+          <a:fillRef idx="3">
+            <a:schemeClr val="accent1"/>
+          </a:fillRef>
+          <a:effectRef idx="2">
+            <a:schemeClr val="accent1"/>
+          </a:effectRef>
+          <a:fontRef idx="minor">
+            <a:schemeClr val="lt1"/>
+          </a:fontRef>
+        </p:style>
+        <p:txBody>
+          <a:bodyPr rtlCol="0" anchor="ctr"/>
+          <a:lstStyle/>
+          <a:p>
+            <a:pPr algn="ctr"/>
+          </a:p>
+        </p:txBody>
+      </p:sp>
+      <p:sp>
+        <p:nvSpPr>
+          <p:cNvPr id="3" name="TextBox 2"/>
+          <p:cNvSpPr txBox="1"/>
+          <p:nvPr/>
+        </p:nvSpPr>
+        <p:spPr>
+          <a:xfrm>
+            <a:off x="548640" y="274320"/>
+            <a:ext cx="11064240" cy="822960"/>
+          </a:xfrm>
+          <a:prstGeom prst="rect">
+            <a:avLst/>
+          </a:prstGeom>
+          <a:noFill/>
+        </p:spPr>
+        <p:txBody>
+          <a:bodyPr wrap="square">
+            <a:spAutoFit/>
+          </a:bodyPr>
+          <a:lstStyle/>
+          <a:p>
+            <a:pPr>
+              <a:spcAft>
+                <a:spcPts val="600"/>
+              </a:spcAft>
+            </a:pPr>
+            <a:r>
+              <a:rPr sz="2800" b="1">
+                <a:solidFill>
+                  <a:srgbClr val="1B1F2A"/>
+                </a:solidFill>
+                <a:latin typeface="Arial"/>
+              </a:rPr>
+              <a:t>Key references</a:t>
+            </a:r>
+          </a:p>
+        </p:txBody>
+      </p:sp>
+      <p:sp>
+        <p:nvSpPr>
+          <p:cNvPr id="4" name="TextBox 3"/>
+          <p:cNvSpPr txBox="1"/>
+          <p:nvPr/>
+        </p:nvSpPr>
+        <p:spPr>
+          <a:xfrm>
+            <a:off x="548640" y="6400800"/>
+            <a:ext cx="8229600" cy="320040"/>
+          </a:xfrm>
+          <a:prstGeom prst="rect">
+            <a:avLst/>
+          </a:prstGeom>
+          <a:noFill/>
+        </p:spPr>
+        <p:txBody>
+          <a:bodyPr wrap="square">
+            <a:spAutoFit/>
+          </a:bodyPr>
+          <a:lstStyle/>
+          <a:p>
+            <a:pPr>
+              <a:spcAft>
+                <a:spcPts val="600"/>
+              </a:spcAft>
+            </a:pPr>
+            <a:r>
+              <a:rPr sz="1000" b="0">
+                <a:solidFill>
+                  <a:srgbClr val="5A6270"/>
+                </a:solidFill>
+                <a:latin typeface="Arial"/>
+              </a:rPr>
+              <a:t>BCSE306L Artificial Intelligence | Adhyan Jain, Atharva Sheerh Pandey, Aryan Gahlot</a:t>
+            </a:r>
+          </a:p>
+        </p:txBody>
+      </p:sp>
+      <p:sp>
+        <p:nvSpPr>
+          <p:cNvPr id="5" name="TextBox 4"/>
+          <p:cNvSpPr txBox="1"/>
+          <p:nvPr/>
+        </p:nvSpPr>
+        <p:spPr>
+          <a:xfrm>
+            <a:off x="10972800" y="6400800"/>
+            <a:ext cx="731520" cy="320040"/>
+          </a:xfrm>
+          <a:prstGeom prst="rect">
+            <a:avLst/>
+          </a:prstGeom>
+          <a:noFill/>
+        </p:spPr>
+        <p:txBody>
+          <a:bodyPr wrap="square">
+            <a:spAutoFit/>
+          </a:bodyPr>
+          <a:lstStyle/>
+          <a:p>
+            <a:pPr algn="r">
+              <a:spcAft>
+                <a:spcPts val="600"/>
+              </a:spcAft>
+            </a:pPr>
+            <a:r>
+              <a:rPr sz="1000" b="0">
+                <a:solidFill>
+                  <a:srgbClr val="5A6270"/>
+                </a:solidFill>
+                <a:latin typeface="Arial"/>
+              </a:rPr>
+              <a:t>16</a:t>
             </a:r>
           </a:p>
         </p:txBody>

</xml_diff>

<commit_message>
course: final rebuild with RF-E2E results of five models
</commit_message>
<xml_diff>
--- a/EchoTales_Research_Presentation.pptx
+++ b/EchoTales_Research_Presentation.pptx
@@ -5821,6 +5821,22 @@
                 <a:latin typeface="Arial"/>
               </a:rPr>
               <a:t>•  Same frozen events and reveal oracle as the confirmatory study; pre-registered (addenda 6 to 8)</a:t>
+            </a:r>
+          </a:p>
+          <a:p>
+            <a:pPr>
+              <a:spcAft>
+                <a:spcPts val="1000"/>
+              </a:spcAft>
+            </a:pPr>
+            <a:r>
+              <a:rPr sz="1700">
+                <a:solidFill>
+                  <a:srgbClr val="1B1F2A"/>
+                </a:solidFill>
+                <a:latin typeface="Arial"/>
+              </a:rPr>
+              <a:t>•  Larger 24-32B models: whole-book card 23.1% vs versioned 1.9%; memory-only +0.0 points</a:t>
             </a:r>
           </a:p>
         </p:txBody>

</xml_diff>

<commit_message>
course: VIT logo on the title page, title reframed around reader-faithfulness; RF-E2E analysis adds the second-judge summary
</commit_message>
<xml_diff>
--- a/EchoTales_Research_Presentation.pptx
+++ b/EchoTales_Research_Presentation.pptx
@@ -4650,7 +4650,7 @@
                 </a:solidFill>
                 <a:latin typeface="Arial"/>
               </a:rPr>
-              <a:t>Do Language Models Peek Ahead?</a:t>
+              <a:t>Do Reading Assistants Peek Ahead?</a:t>
             </a:r>
           </a:p>
         </p:txBody>
@@ -4689,7 +4689,7 @@
                 </a:solidFill>
                 <a:latin typeface="Arial"/>
               </a:rPr>
-              <a:t>Measuring name-keyed memory leakage when LLMs read serialised fiction, on a reader-scoped narrative knowledge graph (EchoTales)</a:t>
+              <a:t>Reader-faithfulness: detecting and fixing look-ahead leaks from the pipeline and from model memory (EchoTales)</a:t>
             </a:r>
           </a:p>
         </p:txBody>

</xml_diff>

<commit_message>
RF-E2E robustness (addendum 10, qwen2.5:7b): don't-spoil baseline and second cipher in the paper (7.6), reports, course document, slides and demo script
</commit_message>
<xml_diff>
--- a/EchoTales_Research_Presentation.pptx
+++ b/EchoTales_Research_Presentation.pptx
@@ -5766,7 +5766,7 @@
               </a:spcAft>
             </a:pPr>
             <a:r>
-              <a:rPr sz="1700">
+              <a:rPr sz="1600">
                 <a:solidFill>
                   <a:srgbClr val="1B1F2A"/>
                 </a:solidFill>
@@ -5782,7 +5782,7 @@
               </a:spcAft>
             </a:pPr>
             <a:r>
-              <a:rPr sz="1700">
+              <a:rPr sz="1600">
                 <a:solidFill>
                   <a:srgbClr val="1B1F2A"/>
                 </a:solidFill>
@@ -5798,7 +5798,7 @@
               </a:spcAft>
             </a:pPr>
             <a:r>
-              <a:rPr sz="1700">
+              <a:rPr sz="1600">
                 <a:solidFill>
                   <a:srgbClr val="1B1F2A"/>
                 </a:solidFill>
@@ -5814,7 +5814,7 @@
               </a:spcAft>
             </a:pPr>
             <a:r>
-              <a:rPr sz="1700">
+              <a:rPr sz="1600">
                 <a:solidFill>
                   <a:srgbClr val="1B1F2A"/>
                 </a:solidFill>
@@ -5830,13 +5830,29 @@
               </a:spcAft>
             </a:pPr>
             <a:r>
-              <a:rPr sz="1700">
+              <a:rPr sz="1600">
                 <a:solidFill>
                   <a:srgbClr val="1B1F2A"/>
                 </a:solidFill>
                 <a:latin typeface="Arial"/>
               </a:rPr>
               <a:t>•  Larger 24-32B models: whole-book card 23.1% vs versioned 1.9%; memory-only +0.0 points</a:t>
+            </a:r>
+          </a:p>
+          <a:p>
+            <a:pPr>
+              <a:spcAft>
+                <a:spcPts val="1000"/>
+              </a:spcAft>
+            </a:pPr>
+            <a:r>
+              <a:rPr sz="1600">
+                <a:solidFill>
+                  <a:srgbClr val="1B1F2A"/>
+                </a:solidFill>
+                <a:latin typeface="Arial"/>
+              </a:rPr>
+              <a:t>•  'Avoid spoilers' instruction: whole-book card still leaks 14.8% vs versioned 0.0%; second cipher input leak +5.6 points</a:t>
             </a:r>
           </a:p>
         </p:txBody>

</xml_diff>

<commit_message>
course and paper: RF-E2E figure, judge-versus-text-rule check and exposure window (post hoc), takeaways and references updated, script refreshed
</commit_message>
<xml_diff>
--- a/EchoTales_Research_Presentation.pptx
+++ b/EchoTales_Research_Presentation.pptx
@@ -937,7 +937,7 @@
           <a:lstStyle/>
           <a:p>
             <a:r>
-              <a:t>Close in thirty seconds, then invite questions. Expect: why not human labels; why local models failed to replicate; is this just contamination; can your system leak.</a:t>
+              <a:t>Close in thirty seconds, then invite questions. Lead with the pipeline result, then the memory boundary.</a:t>
             </a:r>
           </a:p>
         </p:txBody>
@@ -5746,8 +5746,8 @@
         </p:nvSpPr>
         <p:spPr>
           <a:xfrm>
-            <a:off x="640080" y="1371600"/>
-            <a:ext cx="10972800" cy="4572000"/>
+            <a:off x="365760" y="1280160"/>
+            <a:ext cx="5394960" cy="4572000"/>
           </a:xfrm>
           <a:prstGeom prst="rect">
             <a:avLst/>
@@ -5766,7 +5766,7 @@
               </a:spcAft>
             </a:pPr>
             <a:r>
-              <a:rPr sz="1600">
+              <a:rPr sz="1300">
                 <a:solidFill>
                   <a:srgbClr val="1B1F2A"/>
                 </a:solidFill>
@@ -5782,7 +5782,7 @@
               </a:spcAft>
             </a:pPr>
             <a:r>
-              <a:rPr sz="1600">
+              <a:rPr sz="1300">
                 <a:solidFill>
                   <a:srgbClr val="1B1F2A"/>
                 </a:solidFill>
@@ -5798,7 +5798,7 @@
               </a:spcAft>
             </a:pPr>
             <a:r>
-              <a:rPr sz="1600">
+              <a:rPr sz="1300">
                 <a:solidFill>
                   <a:srgbClr val="1B1F2A"/>
                 </a:solidFill>
@@ -5814,7 +5814,7 @@
               </a:spcAft>
             </a:pPr>
             <a:r>
-              <a:rPr sz="1600">
+              <a:rPr sz="1300">
                 <a:solidFill>
                   <a:srgbClr val="1B1F2A"/>
                 </a:solidFill>
@@ -5830,7 +5830,7 @@
               </a:spcAft>
             </a:pPr>
             <a:r>
-              <a:rPr sz="1600">
+              <a:rPr sz="1300">
                 <a:solidFill>
                   <a:srgbClr val="1B1F2A"/>
                 </a:solidFill>
@@ -5846,17 +5846,41 @@
               </a:spcAft>
             </a:pPr>
             <a:r>
-              <a:rPr sz="1600">
+              <a:rPr sz="1300">
                 <a:solidFill>
                   <a:srgbClr val="1B1F2A"/>
                 </a:solidFill>
                 <a:latin typeface="Arial"/>
               </a:rPr>
-              <a:t>•  'Avoid spoilers' instruction: whole-book card still leaks 14.8% vs versioned 0.0%; second cipher input leak +5.6 points</a:t>
-            </a:r>
-          </a:p>
-        </p:txBody>
-      </p:sp>
+              <a:t>•  'Avoid spoilers' instruction: whole-book card still leaks 14.8% vs versioned 0.0%; second cipher input leak +31.6 points (strict text rule)</a:t>
+            </a:r>
+          </a:p>
+        </p:txBody>
+      </p:sp>
+      <p:pic>
+        <p:nvPicPr>
+          <p:cNvPr id="7" name="Picture 6" descr="fig_rf.png"/>
+          <p:cNvPicPr>
+            <a:picLocks noChangeAspect="1"/>
+          </p:cNvPicPr>
+          <p:nvPr/>
+        </p:nvPicPr>
+        <p:blipFill>
+          <a:blip r:embed="rId3"/>
+          <a:stretch>
+            <a:fillRect/>
+          </a:stretch>
+        </p:blipFill>
+        <p:spPr>
+          <a:xfrm>
+            <a:off x="5852160" y="1645920"/>
+            <a:ext cx="6126480" cy="2150786"/>
+          </a:xfrm>
+          <a:prstGeom prst="rect">
+            <a:avLst/>
+          </a:prstGeom>
+        </p:spPr>
+      </p:pic>
     </p:spTree>
   </p:cSld>
   <p:clrMapOvr>
@@ -6312,13 +6336,13 @@
               </a:spcAft>
             </a:pPr>
             <a:r>
-              <a:rPr sz="2000">
+              <a:rPr sz="1900">
                 <a:solidFill>
                   <a:srgbClr val="1B1F2A"/>
                 </a:solidFill>
                 <a:latin typeface="Arial"/>
               </a:rPr>
-              <a:t>•  Name-keyed memory leakage is measurable: +26.0 points [16.8, 36.0] for the strongest model over 38 events.</a:t>
+              <a:t>•  A common assistant design, a whole-book character card, names the hidden identity early in 18.5-23.1% of events even on cipher names: the pipeline leaks, not the model's memory.</a:t>
             </a:r>
           </a:p>
           <a:p>
@@ -6328,13 +6352,13 @@
               </a:spcAft>
             </a:pPr>
             <a:r>
-              <a:rPr sz="2000">
+              <a:rPr sz="1900">
                 <a:solidFill>
                   <a:srgbClr val="1B1F2A"/>
                 </a:solidFill>
                 <a:latin typeface="Arial"/>
               </a:rPr>
-              <a:t>•  It is not explained by lost name cues, and it rises with how well the book is known.</a:t>
+              <a:t>•  A versioned card built from the reader's prefix fixes it (1.2% leak); an 'avoid spoilers' instruction does not.</a:t>
             </a:r>
           </a:p>
           <a:p>
@@ -6344,13 +6368,13 @@
               </a:spcAft>
             </a:pPr>
             <a:r>
-              <a:rPr sz="2000">
+              <a:rPr sz="1900">
                 <a:solidFill>
                   <a:srgbClr val="1B1F2A"/>
                 </a:solidFill>
                 <a:latin typeface="Arial"/>
               </a:rPr>
-              <a:t>•  Small-model results are mixed and a pre-registered replication failed: reported as such.</a:t>
+              <a:t>•  The same look-ahead appears in our own knowledge graph (6.0% of character facts); horizon versioning gives 0, naive hiding is worse.</a:t>
             </a:r>
           </a:p>
           <a:p>
@@ -6360,13 +6384,13 @@
               </a:spcAft>
             </a:pPr>
             <a:r>
-              <a:rPr sz="2000">
+              <a:rPr sz="1900">
                 <a:solidFill>
                   <a:srgbClr val="1B1F2A"/>
                 </a:solidFill>
                 <a:latin typeface="Arial"/>
               </a:rPr>
-              <a:t>•  Reader-faithfulness can be audited by truncate-and-rebuild; one stage of our pipeline failed it.</a:t>
+              <a:t>•  Model memory leaks on famous books (+26.0 points, exploratory) and stays under about 5 points on obscure ones (pre-registered).</a:t>
             </a:r>
           </a:p>
           <a:p>
@@ -6376,13 +6400,13 @@
               </a:spcAft>
             </a:pPr>
             <a:r>
-              <a:rPr sz="2000">
+              <a:rPr sz="1900">
                 <a:solidFill>
                   <a:srgbClr val="1B1F2A"/>
                 </a:solidFill>
                 <a:latin typeface="Arial"/>
               </a:rPr>
-              <a:t>•  A pre-registered confirmatory run on obscure books did not detect the effect; the limits are stated.</a:t>
+              <a:t>•  All tests were pre-registered; nulls are reported as nulls; no human labels are claimed.</a:t>
             </a:r>
           </a:p>
         </p:txBody>

</xml_diff>

<commit_message>
course: slides reordered to follow the demo script, RQ4 for the pipeline result, limits slide and script numbers aligned
</commit_message>
<xml_diff>
--- a/EchoTales_Research_Presentation.pptx
+++ b/EchoTales_Research_Presentation.pptx
@@ -13,13 +13,13 @@
     <p:sldId id="261" r:id="rId13"/>
     <p:sldId id="262" r:id="rId14"/>
     <p:sldId id="263" r:id="rId15"/>
+    <p:sldId id="267" r:id="rId19"/>
     <p:sldId id="264" r:id="rId16"/>
+    <p:sldId id="268" r:id="rId20"/>
     <p:sldId id="265" r:id="rId17"/>
     <p:sldId id="266" r:id="rId18"/>
-    <p:sldId id="267" r:id="rId19"/>
-    <p:sldId id="268" r:id="rId20"/>
+    <p:sldId id="270" r:id="rId22"/>
     <p:sldId id="269" r:id="rId21"/>
-    <p:sldId id="270" r:id="rId22"/>
     <p:sldId id="271" r:id="rId23"/>
   </p:sldIdLst>
   <p:sldSz cx="12191695" cy="6858000" type="screen4x3"/>
@@ -1147,7 +1147,7 @@
           <a:lstStyle/>
           <a:p>
             <a:r>
-              <a:t>Read the three questions. Stress that each is answered with a measured number or an explicit null. Mention that hypotheses and thresholds were written and hashed before the data.</a:t>
+              <a:t>Read the four questions. Stress that each is answered with a measured number or an explicit null. Mention that hypotheses and thresholds were written and hashed before the data.</a:t>
             </a:r>
           </a:p>
         </p:txBody>
@@ -5220,13 +5220,13 @@
               </a:spcAft>
             </a:pPr>
             <a:r>
-              <a:rPr sz="1900">
+              <a:rPr sz="1800">
                 <a:solidFill>
                   <a:srgbClr val="1B1F2A"/>
                 </a:solidFill>
                 <a:latin typeface="Arial"/>
               </a:rPr>
-              <a:t>•  Events are model-drafted and verified by exact text search; no event has been checked by a person. No human annotation is used or claimed.</a:t>
+              <a:t>•  Events were selected by a model and checked against the book's text, not by people. No human annotation is used or claimed.</a:t>
             </a:r>
           </a:p>
           <a:p>
@@ -5236,13 +5236,13 @@
               </a:spcAft>
             </a:pPr>
             <a:r>
-              <a:rPr sz="1900">
+              <a:rPr sz="1800">
                 <a:solidFill>
                   <a:srgbClr val="1B1F2A"/>
                 </a:solidFill>
                 <a:latin typeface="Arial"/>
               </a:rPr>
-              <a:t>•  The strongest model leaks clearly; small models leak where they know the book; their replication on seven obscure books failed.</a:t>
+              <a:t>•  One leak rule uses a judge model; checked against the strict text rule it finds 92% of leaks with 0.9% false alarms (kappa 0.92).</a:t>
             </a:r>
           </a:p>
           <a:p>
@@ -5252,13 +5252,13 @@
               </a:spcAft>
             </a:pPr>
             <a:r>
-              <a:rPr sz="1900">
+              <a:rPr sz="1800">
                 <a:solidFill>
                   <a:srgbClr val="1B1F2A"/>
                 </a:solidFill>
                 <a:latin typeface="Arial"/>
               </a:rPr>
-              <a:t>•  Dose-response is post hoc. The memory probes give the book title. Pseudonyms are heuristic.</a:t>
+              <a:t>•  One card prompt and one reader position per event in the main test; extra positions, a second prompt and a second cipher were run on one model.</a:t>
             </a:r>
           </a:p>
           <a:p>
@@ -5268,13 +5268,13 @@
               </a:spcAft>
             </a:pPr>
             <a:r>
-              <a:rPr sz="1900">
+              <a:rPr sz="1800">
                 <a:solidFill>
                   <a:srgbClr val="1B1F2A"/>
                 </a:solidFill>
                 <a:latin typeface="Arial"/>
               </a:rPr>
-              <a:t>•  No claim that EchoTales or any web-serial system leaks; only that two of its stages were audited.</a:t>
+              <a:t>•  Memory leakage is clear only on famous books (exploratory); on obscure books it stays under about 5 points.</a:t>
             </a:r>
           </a:p>
           <a:p>
@@ -5284,13 +5284,13 @@
               </a:spcAft>
             </a:pPr>
             <a:r>
-              <a:rPr sz="1900">
+              <a:rPr sz="1800">
                 <a:solidFill>
                   <a:srgbClr val="1B1F2A"/>
                 </a:solidFill>
                 <a:latin typeface="Arial"/>
               </a:rPr>
-              <a:t>•  Reference model via API: about USD 0.43 in total (ledgered).</a:t>
+              <a:t>•  All tests were pre-registered before their results existed; nulls are reported as nulls.</a:t>
             </a:r>
           </a:p>
         </p:txBody>
@@ -5766,7 +5766,7 @@
               </a:spcAft>
             </a:pPr>
             <a:r>
-              <a:rPr sz="1300">
+              <a:rPr sz="1200">
                 <a:solidFill>
                   <a:srgbClr val="1B1F2A"/>
                 </a:solidFill>
@@ -5782,7 +5782,7 @@
               </a:spcAft>
             </a:pPr>
             <a:r>
-              <a:rPr sz="1300">
+              <a:rPr sz="1200">
                 <a:solidFill>
                   <a:srgbClr val="1B1F2A"/>
                 </a:solidFill>
@@ -5798,7 +5798,7 @@
               </a:spcAft>
             </a:pPr>
             <a:r>
-              <a:rPr sz="1300">
+              <a:rPr sz="1200">
                 <a:solidFill>
                   <a:srgbClr val="1B1F2A"/>
                 </a:solidFill>
@@ -5814,7 +5814,7 @@
               </a:spcAft>
             </a:pPr>
             <a:r>
-              <a:rPr sz="1300">
+              <a:rPr sz="1200">
                 <a:solidFill>
                   <a:srgbClr val="1B1F2A"/>
                 </a:solidFill>
@@ -5830,7 +5830,7 @@
               </a:spcAft>
             </a:pPr>
             <a:r>
-              <a:rPr sz="1300">
+              <a:rPr sz="1200">
                 <a:solidFill>
                   <a:srgbClr val="1B1F2A"/>
                 </a:solidFill>
@@ -5846,7 +5846,7 @@
               </a:spcAft>
             </a:pPr>
             <a:r>
-              <a:rPr sz="1300">
+              <a:rPr sz="1200">
                 <a:solidFill>
                   <a:srgbClr val="1B1F2A"/>
                 </a:solidFill>
@@ -7219,7 +7219,7 @@
               </a:spcAft>
             </a:pPr>
             <a:r>
-              <a:rPr sz="2000">
+              <a:rPr sz="1800">
                 <a:solidFill>
                   <a:srgbClr val="1B1F2A"/>
                 </a:solidFill>
@@ -7235,7 +7235,7 @@
               </a:spcAft>
             </a:pPr>
             <a:r>
-              <a:rPr sz="2000">
+              <a:rPr sz="1800">
                 <a:solidFill>
                   <a:srgbClr val="1B1F2A"/>
                 </a:solidFill>
@@ -7251,13 +7251,13 @@
               </a:spcAft>
             </a:pPr>
             <a:r>
-              <a:rPr sz="2000">
+              <a:rPr sz="1800">
                 <a:solidFill>
                   <a:srgbClr val="1B1F2A"/>
                 </a:solidFill>
                 <a:latin typeface="Arial"/>
               </a:rPr>
-              <a:t>•  RQ3  Does the gap grow with how well-known the book is, and does our own graph pipeline look ahead?  (dose-response, truncate-and-rebuild)</a:t>
+              <a:t>•  RQ3  Does the gap grow with how well-known the book is?  (dose-response; pre-registered confirmatory run)</a:t>
             </a:r>
           </a:p>
           <a:p>
@@ -7267,7 +7267,23 @@
               </a:spcAft>
             </a:pPr>
             <a:r>
-              <a:rPr sz="2000">
+              <a:rPr sz="1800">
+                <a:solidFill>
+                  <a:srgbClr val="1B1F2A"/>
+                </a:solidFill>
+                <a:latin typeface="Arial"/>
+              </a:rPr>
+              <a:t>•  RQ4  Does the pipeline itself leak: our own graph, and a common whole-book character card? Does versioning fix it?  (truncate-and-rebuild, cipher names)</a:t>
+            </a:r>
+          </a:p>
+          <a:p>
+            <a:pPr>
+              <a:spcAft>
+                <a:spcPts val="1000"/>
+              </a:spcAft>
+            </a:pPr>
+            <a:r>
+              <a:rPr sz="1800">
                 <a:solidFill>
                   <a:srgbClr val="1B1F2A"/>
                 </a:solidFill>
@@ -8607,7 +8623,7 @@
                 </a:solidFill>
                 <a:latin typeface="Arial"/>
               </a:rPr>
-              <a:t>•  Post hoc here; tested again in the confirmatory run (slide 12)</a:t>
+              <a:t>•  Post hoc here; tested again in the confirmatory run (next slide)</a:t>
             </a:r>
           </a:p>
         </p:txBody>
@@ -8818,7 +8834,7 @@
               </a:spcAft>
             </a:pPr>
             <a:r>
-              <a:rPr sz="1900">
+              <a:rPr sz="1800">
                 <a:solidFill>
                   <a:srgbClr val="1B1F2A"/>
                 </a:solidFill>
@@ -8834,7 +8850,7 @@
               </a:spcAft>
             </a:pPr>
             <a:r>
-              <a:rPr sz="1900">
+              <a:rPr sz="1800">
                 <a:solidFill>
                   <a:srgbClr val="1B1F2A"/>
                 </a:solidFill>
@@ -8850,7 +8866,7 @@
               </a:spcAft>
             </a:pPr>
             <a:r>
-              <a:rPr sz="1900">
+              <a:rPr sz="1800">
                 <a:solidFill>
                   <a:srgbClr val="1B1F2A"/>
                 </a:solidFill>
@@ -8866,13 +8882,13 @@
               </a:spcAft>
             </a:pPr>
             <a:r>
-              <a:rPr sz="1900">
+              <a:rPr sz="1800">
                 <a:solidFill>
                   <a:srgbClr val="1B1F2A"/>
                 </a:solidFill>
                 <a:latin typeface="Arial"/>
               </a:rPr>
-              <a:t>•  A statistical error we found and fixed: items inside one event are not independent, so intervals now resample events.</a:t>
+              <a:t>•  Repair: version each fact by the chapter its evidence came from: 0 divergences. Hiding every exposed fact is worse than doing nothing (82 vs 23 of 289).</a:t>
             </a:r>
           </a:p>
         </p:txBody>

</xml_diff>

<commit_message>
addendum 11 results (earlier positions, second prompt) in paper 7.8, reports, course files and Research page; page headline shows the current results, outdated plan panel removed; slide numbers follow the new order
</commit_message>
<xml_diff>
--- a/EchoTales_Research_Presentation.pptx
+++ b/EchoTales_Research_Presentation.pptx
@@ -4922,7 +4922,7 @@
                 </a:solidFill>
                 <a:latin typeface="Arial"/>
               </a:rPr>
-              <a:t>10</a:t>
+              <a:t>12</a:t>
             </a:r>
           </a:p>
         </p:txBody>
@@ -5187,7 +5187,7 @@
                 </a:solidFill>
                 <a:latin typeface="Arial"/>
               </a:rPr>
-              <a:t>11</a:t>
+              <a:t>13</a:t>
             </a:r>
           </a:p>
         </p:txBody>
@@ -5468,7 +5468,7 @@
                 </a:solidFill>
                 <a:latin typeface="Arial"/>
               </a:rPr>
-              <a:t>12</a:t>
+              <a:t>9</a:t>
             </a:r>
           </a:p>
         </p:txBody>
@@ -5733,7 +5733,7 @@
                 </a:solidFill>
                 <a:latin typeface="Arial"/>
               </a:rPr>
-              <a:t>13</a:t>
+              <a:t>11</a:t>
             </a:r>
           </a:p>
         </p:txBody>
@@ -5853,6 +5853,22 @@
                 <a:latin typeface="Arial"/>
               </a:rPr>
               <a:t>•  'Avoid spoilers' instruction: whole-book card still leaks 14.8% vs versioned 0.0%; second cipher input leak +31.6 points (strict text rule)</a:t>
+            </a:r>
+          </a:p>
+          <a:p>
+            <a:pPr>
+              <a:spcAft>
+                <a:spcPts val="1000"/>
+              </a:spcAft>
+            </a:pPr>
+            <a:r>
+              <a:rPr sz="1200">
+                <a:solidFill>
+                  <a:srgbClr val="1B1F2A"/>
+                </a:solidFill>
+                <a:latin typeface="Arial"/>
+              </a:rPr>
+              <a:t>•  Earlier reader positions: versioned card 1.9% / 1.9% vs whole-book 16.7%; second prompt input leak +18.5 points</a:t>
             </a:r>
           </a:p>
         </p:txBody>
@@ -6054,7 +6070,7 @@
                 </a:solidFill>
                 <a:latin typeface="Arial"/>
               </a:rPr>
-              <a:t>14</a:t>
+              <a:t>15</a:t>
             </a:r>
           </a:p>
         </p:txBody>
@@ -6303,7 +6319,7 @@
                 </a:solidFill>
                 <a:latin typeface="Arial"/>
               </a:rPr>
-              <a:t>15</a:t>
+              <a:t>14</a:t>
             </a:r>
           </a:p>
         </p:txBody>
@@ -8801,7 +8817,7 @@
                 </a:solidFill>
                 <a:latin typeface="Arial"/>
               </a:rPr>
-              <a:t>9</a:t>
+              <a:t>10</a:t>
             </a:r>
           </a:p>
         </p:txBody>

</xml_diff>

<commit_message>
course: unnumbered section headings, abstract split by label, name spelling, provenance note and branch name removed, final video and repository links
</commit_message>
<xml_diff>
--- a/EchoTales_Research_Presentation.pptx
+++ b/EchoTales_Research_Presentation.pptx
@@ -4728,7 +4728,7 @@
                 </a:solidFill>
                 <a:latin typeface="Arial"/>
               </a:rPr>
-              <a:t>Adhyan Jain (24BCI0111)   Atharva Sheerh Pandey (24BCI0069)   Aryan Gahlot (24BCI0033)</a:t>
+              <a:t>Adhyan Jain (24BCI0111)   Atharva Sheersh Pandey (24BCI0069)   Aryan Gahlot (24BCI0033)</a:t>
             </a:r>
           </a:p>
           <a:p>
@@ -4883,7 +4883,7 @@
                 </a:solidFill>
                 <a:latin typeface="Arial"/>
               </a:rPr>
-              <a:t>BCSE306L Artificial Intelligence | Adhyan Jain, Atharva Sheerh Pandey, Aryan Gahlot</a:t>
+              <a:t>BCSE306L Artificial Intelligence | Adhyan Jain, Atharva Sheersh Pandey, Aryan Gahlot</a:t>
             </a:r>
           </a:p>
         </p:txBody>
@@ -5148,7 +5148,7 @@
                 </a:solidFill>
                 <a:latin typeface="Arial"/>
               </a:rPr>
-              <a:t>BCSE306L Artificial Intelligence | Adhyan Jain, Atharva Sheerh Pandey, Aryan Gahlot</a:t>
+              <a:t>BCSE306L Artificial Intelligence | Adhyan Jain, Atharva Sheersh Pandey, Aryan Gahlot</a:t>
             </a:r>
           </a:p>
         </p:txBody>
@@ -5429,7 +5429,7 @@
                 </a:solidFill>
                 <a:latin typeface="Arial"/>
               </a:rPr>
-              <a:t>BCSE306L Artificial Intelligence | Adhyan Jain, Atharva Sheerh Pandey, Aryan Gahlot</a:t>
+              <a:t>BCSE306L Artificial Intelligence | Adhyan Jain, Atharva Sheersh Pandey, Aryan Gahlot</a:t>
             </a:r>
           </a:p>
         </p:txBody>
@@ -5694,7 +5694,7 @@
                 </a:solidFill>
                 <a:latin typeface="Arial"/>
               </a:rPr>
-              <a:t>BCSE306L Artificial Intelligence | Adhyan Jain, Atharva Sheerh Pandey, Aryan Gahlot</a:t>
+              <a:t>BCSE306L Artificial Intelligence | Adhyan Jain, Atharva Sheersh Pandey, Aryan Gahlot</a:t>
             </a:r>
           </a:p>
         </p:txBody>
@@ -6031,7 +6031,7 @@
                 </a:solidFill>
                 <a:latin typeface="Arial"/>
               </a:rPr>
-              <a:t>BCSE306L Artificial Intelligence | Adhyan Jain, Atharva Sheerh Pandey, Aryan Gahlot</a:t>
+              <a:t>BCSE306L Artificial Intelligence | Adhyan Jain, Atharva Sheersh Pandey, Aryan Gahlot</a:t>
             </a:r>
           </a:p>
         </p:txBody>
@@ -6125,7 +6125,7 @@
                 </a:solidFill>
                 <a:latin typeface="Arial"/>
               </a:rPr>
-              <a:t>•  Atharva Sheerh Pandey (24BCI0069): Alias-reveal task formulation, Gutenberg event mining, multi-arm renaming controls (cipher &amp; pseudonyms), local model test harness, and live probe UI.</a:t>
+              <a:t>•  Atharva Sheersh Pandey (24BCI0069): Alias-reveal task formulation, Gutenberg event mining, multi-arm renaming controls (cipher &amp; pseudonyms), local model test harness, and live probe UI.</a:t>
             </a:r>
           </a:p>
           <a:p>
@@ -6280,7 +6280,7 @@
                 </a:solidFill>
                 <a:latin typeface="Arial"/>
               </a:rPr>
-              <a:t>BCSE306L Artificial Intelligence | Adhyan Jain, Atharva Sheerh Pandey, Aryan Gahlot</a:t>
+              <a:t>BCSE306L Artificial Intelligence | Adhyan Jain, Atharva Sheersh Pandey, Aryan Gahlot</a:t>
             </a:r>
           </a:p>
         </p:txBody>
@@ -6561,7 +6561,7 @@
                 </a:solidFill>
                 <a:latin typeface="Arial"/>
               </a:rPr>
-              <a:t>BCSE306L Artificial Intelligence | Adhyan Jain, Atharva Sheerh Pandey, Aryan Gahlot</a:t>
+              <a:t>BCSE306L Artificial Intelligence | Adhyan Jain, Atharva Sheersh Pandey, Aryan Gahlot</a:t>
             </a:r>
           </a:p>
         </p:txBody>
@@ -6874,7 +6874,7 @@
                 </a:solidFill>
                 <a:latin typeface="Arial"/>
               </a:rPr>
-              <a:t>BCSE306L Artificial Intelligence | Adhyan Jain, Atharva Sheerh Pandey, Aryan Gahlot</a:t>
+              <a:t>BCSE306L Artificial Intelligence | Adhyan Jain, Atharva Sheersh Pandey, Aryan Gahlot</a:t>
             </a:r>
           </a:p>
         </p:txBody>
@@ -7163,7 +7163,7 @@
                 </a:solidFill>
                 <a:latin typeface="Arial"/>
               </a:rPr>
-              <a:t>BCSE306L Artificial Intelligence | Adhyan Jain, Atharva Sheerh Pandey, Aryan Gahlot</a:t>
+              <a:t>BCSE306L Artificial Intelligence | Adhyan Jain, Atharva Sheersh Pandey, Aryan Gahlot</a:t>
             </a:r>
           </a:p>
         </p:txBody>
@@ -7444,7 +7444,7 @@
                 </a:solidFill>
                 <a:latin typeface="Arial"/>
               </a:rPr>
-              <a:t>BCSE306L Artificial Intelligence | Adhyan Jain, Atharva Sheerh Pandey, Aryan Gahlot</a:t>
+              <a:t>BCSE306L Artificial Intelligence | Adhyan Jain, Atharva Sheersh Pandey, Aryan Gahlot</a:t>
             </a:r>
           </a:p>
         </p:txBody>
@@ -7725,7 +7725,7 @@
                 </a:solidFill>
                 <a:latin typeface="Arial"/>
               </a:rPr>
-              <a:t>BCSE306L Artificial Intelligence | Adhyan Jain, Atharva Sheerh Pandey, Aryan Gahlot</a:t>
+              <a:t>BCSE306L Artificial Intelligence | Adhyan Jain, Atharva Sheersh Pandey, Aryan Gahlot</a:t>
             </a:r>
           </a:p>
         </p:txBody>
@@ -7927,7 +7927,7 @@
                 </a:solidFill>
                 <a:latin typeface="Arial"/>
               </a:rPr>
-              <a:t>BCSE306L Artificial Intelligence | Adhyan Jain, Atharva Sheerh Pandey, Aryan Gahlot</a:t>
+              <a:t>BCSE306L Artificial Intelligence | Adhyan Jain, Atharva Sheersh Pandey, Aryan Gahlot</a:t>
             </a:r>
           </a:p>
         </p:txBody>
@@ -8216,7 +8216,7 @@
                 </a:solidFill>
                 <a:latin typeface="Arial"/>
               </a:rPr>
-              <a:t>BCSE306L Artificial Intelligence | Adhyan Jain, Atharva Sheerh Pandey, Aryan Gahlot</a:t>
+              <a:t>BCSE306L Artificial Intelligence | Adhyan Jain, Atharva Sheersh Pandey, Aryan Gahlot</a:t>
             </a:r>
           </a:p>
         </p:txBody>
@@ -8505,7 +8505,7 @@
                 </a:solidFill>
                 <a:latin typeface="Arial"/>
               </a:rPr>
-              <a:t>BCSE306L Artificial Intelligence | Adhyan Jain, Atharva Sheerh Pandey, Aryan Gahlot</a:t>
+              <a:t>BCSE306L Artificial Intelligence | Adhyan Jain, Atharva Sheersh Pandey, Aryan Gahlot</a:t>
             </a:r>
           </a:p>
         </p:txBody>
@@ -8778,7 +8778,7 @@
                 </a:solidFill>
                 <a:latin typeface="Arial"/>
               </a:rPr>
-              <a:t>BCSE306L Artificial Intelligence | Adhyan Jain, Atharva Sheerh Pandey, Aryan Gahlot</a:t>
+              <a:t>BCSE306L Artificial Intelligence | Adhyan Jain, Atharva Sheersh Pandey, Aryan Gahlot</a:t>
             </a:r>
           </a:p>
         </p:txBody>

</xml_diff>